<commit_message>
fix poster template alignment issues
</commit_message>
<xml_diff>
--- a/assets/downloads/cici-IPAAI-pi-poster-template-2026.pptx
+++ b/assets/downloads/cici-IPAAI-pi-poster-template-2026.pptx
@@ -8,7 +8,7 @@
     <p:notesMasterId r:id="rId3"/>
   </p:notesMasterIdLst>
   <p:sldIdLst>
-    <p:sldId id="258" r:id="rId2"/>
+    <p:sldId id="261" r:id="rId2"/>
   </p:sldIdLst>
   <p:sldSz cx="31089600" cy="36576000"/>
   <p:notesSz cx="6858000" cy="9144000"/>
@@ -507,7 +507,7 @@
         </p:nvSpPr>
         <p:spPr>
           <a:xfrm>
-            <a:off x="1483924" y="747213"/>
+            <a:off x="1510817" y="747213"/>
             <a:ext cx="28333428" cy="3155591"/>
           </a:xfrm>
           <a:prstGeom prst="rect">
@@ -548,7 +548,7 @@
         </p:nvSpPr>
         <p:spPr>
           <a:xfrm>
-            <a:off x="1537712" y="5349773"/>
+            <a:off x="1510817" y="5349773"/>
             <a:ext cx="28333428" cy="1400005"/>
           </a:xfrm>
           <a:prstGeom prst="rect">
@@ -592,7 +592,7 @@
         </p:nvSpPr>
         <p:spPr>
           <a:xfrm>
-            <a:off x="1483924" y="4001336"/>
+            <a:off x="1510817" y="4001336"/>
             <a:ext cx="28333428" cy="1079498"/>
           </a:xfrm>
           <a:prstGeom prst="rect">
@@ -636,7 +636,7 @@
         </p:nvSpPr>
         <p:spPr>
           <a:xfrm>
-            <a:off x="1483924" y="19827116"/>
+            <a:off x="1510817" y="19827116"/>
             <a:ext cx="28333429" cy="5080000"/>
           </a:xfrm>
           <a:prstGeom prst="rect">
@@ -741,8 +741,8 @@
         </p:nvSpPr>
         <p:spPr>
           <a:xfrm>
-            <a:off x="10976095" y="25924040"/>
-            <a:ext cx="9137409" cy="7644323"/>
+            <a:off x="11108827" y="25742481"/>
+            <a:ext cx="9137409" cy="7805687"/>
           </a:xfrm>
           <a:prstGeom prst="rect">
             <a:avLst/>
@@ -811,7 +811,7 @@
           </a:p>
           <a:p>
             <a:pPr lvl="0"/>
-            <a:endParaRPr lang="en-US"/>
+            <a:endParaRPr lang="en-US" dirty="0"/>
           </a:p>
           <a:p>
             <a:pPr lvl="0"/>
@@ -863,7 +863,7 @@
         </p:nvSpPr>
         <p:spPr>
           <a:xfrm>
-            <a:off x="1483923" y="11670716"/>
+            <a:off x="1510817" y="11670716"/>
             <a:ext cx="28333429" cy="7741736"/>
           </a:xfrm>
           <a:prstGeom prst="rect">
@@ -984,8 +984,8 @@
         </p:nvSpPr>
         <p:spPr>
           <a:xfrm>
-            <a:off x="1743994" y="25816463"/>
-            <a:ext cx="8877338" cy="7805687"/>
+            <a:off x="1510817" y="25742481"/>
+            <a:ext cx="9134856" cy="7805687"/>
           </a:xfrm>
           <a:prstGeom prst="rect">
             <a:avLst/>
@@ -1105,8 +1105,8 @@
         </p:nvSpPr>
         <p:spPr>
           <a:xfrm>
-            <a:off x="20679943" y="25944236"/>
-            <a:ext cx="9137409" cy="7603932"/>
+            <a:off x="20706836" y="25742481"/>
+            <a:ext cx="9137409" cy="7805687"/>
           </a:xfrm>
           <a:prstGeom prst="rect">
             <a:avLst/>
@@ -1219,7 +1219,7 @@
         </p:nvSpPr>
         <p:spPr>
           <a:xfrm>
-            <a:off x="1483924" y="8096624"/>
+            <a:off x="1510817" y="8096624"/>
             <a:ext cx="28333429" cy="3089440"/>
           </a:xfrm>
           <a:prstGeom prst="rect">
@@ -1950,10 +1950,10 @@
       </p:grpSpPr>
       <p:sp>
         <p:nvSpPr>
-          <p:cNvPr id="14" name="Title 13">
+          <p:cNvPr id="2" name="Title 1">
             <a:extLst>
               <a:ext uri="{FF2B5EF4-FFF2-40B4-BE49-F238E27FC236}">
-                <a16:creationId xmlns:a16="http://schemas.microsoft.com/office/drawing/2014/main" id="{09017078-4B12-9245-882C-7504E078825A}"/>
+                <a16:creationId xmlns:a16="http://schemas.microsoft.com/office/drawing/2014/main" id="{A3706610-4C03-E056-DF73-45895AFE74EB}"/>
               </a:ext>
             </a:extLst>
           </p:cNvPr>
@@ -1975,10 +1975,10 @@
       </p:sp>
       <p:sp>
         <p:nvSpPr>
-          <p:cNvPr id="15" name="Text Placeholder 14">
+          <p:cNvPr id="3" name="Text Placeholder 2">
             <a:extLst>
               <a:ext uri="{FF2B5EF4-FFF2-40B4-BE49-F238E27FC236}">
-                <a16:creationId xmlns:a16="http://schemas.microsoft.com/office/drawing/2014/main" id="{A5BBDF55-3C22-6C45-97D6-C341840652E2}"/>
+                <a16:creationId xmlns:a16="http://schemas.microsoft.com/office/drawing/2014/main" id="{F132697F-8AE1-7708-4E66-F54B96933BA5}"/>
               </a:ext>
             </a:extLst>
           </p:cNvPr>
@@ -1994,16 +1994,16 @@
           <a:bodyPr/>
           <a:lstStyle/>
           <a:p>
-            <a:endParaRPr lang="en-US" dirty="0"/>
+            <a:endParaRPr lang="en-US"/>
           </a:p>
         </p:txBody>
       </p:sp>
       <p:sp>
         <p:nvSpPr>
-          <p:cNvPr id="16" name="Text Placeholder 15">
+          <p:cNvPr id="4" name="Text Placeholder 3">
             <a:extLst>
               <a:ext uri="{FF2B5EF4-FFF2-40B4-BE49-F238E27FC236}">
-                <a16:creationId xmlns:a16="http://schemas.microsoft.com/office/drawing/2014/main" id="{3215BA45-653D-A740-9AE6-B08AF807E6BA}"/>
+                <a16:creationId xmlns:a16="http://schemas.microsoft.com/office/drawing/2014/main" id="{82486F73-0BE6-1D4D-6AAF-36F2BE5AA7CD}"/>
               </a:ext>
             </a:extLst>
           </p:cNvPr>
@@ -2025,10 +2025,10 @@
       </p:sp>
       <p:sp>
         <p:nvSpPr>
-          <p:cNvPr id="17" name="Content Placeholder 16">
+          <p:cNvPr id="5" name="Content Placeholder 4">
             <a:extLst>
               <a:ext uri="{FF2B5EF4-FFF2-40B4-BE49-F238E27FC236}">
-                <a16:creationId xmlns:a16="http://schemas.microsoft.com/office/drawing/2014/main" id="{5800D70B-D3D9-B747-91C3-742ABBD61BF4}"/>
+                <a16:creationId xmlns:a16="http://schemas.microsoft.com/office/drawing/2014/main" id="{E86B27C0-37CF-6529-D424-F4D0836DD412}"/>
               </a:ext>
             </a:extLst>
           </p:cNvPr>
@@ -2050,10 +2050,10 @@
       </p:sp>
       <p:sp>
         <p:nvSpPr>
-          <p:cNvPr id="18" name="Content Placeholder 17">
+          <p:cNvPr id="6" name="Content Placeholder 5">
             <a:extLst>
               <a:ext uri="{FF2B5EF4-FFF2-40B4-BE49-F238E27FC236}">
-                <a16:creationId xmlns:a16="http://schemas.microsoft.com/office/drawing/2014/main" id="{F2CA2ED7-343B-5E4D-8E26-7D30B108F679}"/>
+                <a16:creationId xmlns:a16="http://schemas.microsoft.com/office/drawing/2014/main" id="{745766B9-A84A-C223-673D-400D75EA412F}"/>
               </a:ext>
             </a:extLst>
           </p:cNvPr>
@@ -2075,10 +2075,10 @@
       </p:sp>
       <p:sp>
         <p:nvSpPr>
-          <p:cNvPr id="19" name="Content Placeholder 18">
+          <p:cNvPr id="7" name="Content Placeholder 6">
             <a:extLst>
               <a:ext uri="{FF2B5EF4-FFF2-40B4-BE49-F238E27FC236}">
-                <a16:creationId xmlns:a16="http://schemas.microsoft.com/office/drawing/2014/main" id="{A691B863-EED5-7640-B34C-B389DD69C3C6}"/>
+                <a16:creationId xmlns:a16="http://schemas.microsoft.com/office/drawing/2014/main" id="{84BC5E4B-B472-91B6-D23B-AC61884A57CD}"/>
               </a:ext>
             </a:extLst>
           </p:cNvPr>
@@ -2100,10 +2100,10 @@
       </p:sp>
       <p:sp>
         <p:nvSpPr>
-          <p:cNvPr id="20" name="Content Placeholder 19">
+          <p:cNvPr id="8" name="Content Placeholder 7">
             <a:extLst>
               <a:ext uri="{FF2B5EF4-FFF2-40B4-BE49-F238E27FC236}">
-                <a16:creationId xmlns:a16="http://schemas.microsoft.com/office/drawing/2014/main" id="{E18E915D-4082-2441-B0A3-F40619ABE1D0}"/>
+                <a16:creationId xmlns:a16="http://schemas.microsoft.com/office/drawing/2014/main" id="{28E2AA64-37BF-5607-1805-5A4ED4CCEBA5}"/>
               </a:ext>
             </a:extLst>
           </p:cNvPr>
@@ -2125,10 +2125,10 @@
       </p:sp>
       <p:sp>
         <p:nvSpPr>
-          <p:cNvPr id="21" name="Content Placeholder 20">
+          <p:cNvPr id="9" name="Content Placeholder 8">
             <a:extLst>
               <a:ext uri="{FF2B5EF4-FFF2-40B4-BE49-F238E27FC236}">
-                <a16:creationId xmlns:a16="http://schemas.microsoft.com/office/drawing/2014/main" id="{B40800FA-972E-B04D-A145-322861F30463}"/>
+                <a16:creationId xmlns:a16="http://schemas.microsoft.com/office/drawing/2014/main" id="{4B47F05C-1637-5194-6FBC-811A38725242}"/>
               </a:ext>
             </a:extLst>
           </p:cNvPr>
@@ -2136,18 +2136,10 @@
             <a:spLocks noGrp="1"/>
           </p:cNvSpPr>
           <p:nvPr>
-            <p:ph sz="half" idx="4294967295"/>
+            <p:ph sz="half" idx="23"/>
           </p:nvPr>
         </p:nvSpPr>
-        <p:spPr>
-          <a:xfrm>
-            <a:off x="11095164" y="25487723"/>
-            <a:ext cx="9137409" cy="7603932"/>
-          </a:xfrm>
-          <a:prstGeom prst="rect">
-            <a:avLst/>
-          </a:prstGeom>
-        </p:spPr>
+        <p:spPr/>
         <p:txBody>
           <a:bodyPr/>
           <a:lstStyle/>
@@ -2158,10 +2150,10 @@
       </p:sp>
       <p:sp>
         <p:nvSpPr>
-          <p:cNvPr id="22" name="Content Placeholder 21">
+          <p:cNvPr id="10" name="Content Placeholder 9">
             <a:extLst>
               <a:ext uri="{FF2B5EF4-FFF2-40B4-BE49-F238E27FC236}">
-                <a16:creationId xmlns:a16="http://schemas.microsoft.com/office/drawing/2014/main" id="{C7A5D4FD-9CC3-2D48-826B-8D1C4F4DC0B3}"/>
+                <a16:creationId xmlns:a16="http://schemas.microsoft.com/office/drawing/2014/main" id="{BFE1EE19-396C-2C58-D4CE-57866851AD09}"/>
               </a:ext>
             </a:extLst>
           </p:cNvPr>
@@ -2169,435 +2161,22 @@
             <a:spLocks noGrp="1"/>
           </p:cNvSpPr>
           <p:nvPr>
-            <p:ph sz="half" idx="4294967295"/>
+            <p:ph sz="half" idx="25"/>
           </p:nvPr>
         </p:nvSpPr>
-        <p:spPr>
-          <a:xfrm>
-            <a:off x="20679945" y="25487723"/>
-            <a:ext cx="9137409" cy="7603932"/>
-          </a:xfrm>
-          <a:prstGeom prst="rect">
-            <a:avLst/>
-          </a:prstGeom>
-        </p:spPr>
+        <p:spPr/>
         <p:txBody>
           <a:bodyPr/>
           <a:lstStyle/>
           <a:p>
             <a:endParaRPr lang="en-US"/>
-          </a:p>
-        </p:txBody>
-      </p:sp>
-      <p:sp>
-        <p:nvSpPr>
-          <p:cNvPr id="23" name="Content Placeholder 22">
-            <a:extLst>
-              <a:ext uri="{FF2B5EF4-FFF2-40B4-BE49-F238E27FC236}">
-                <a16:creationId xmlns:a16="http://schemas.microsoft.com/office/drawing/2014/main" id="{95021A7A-D49B-AE44-A9A4-A42E89A41938}"/>
-              </a:ext>
-            </a:extLst>
-          </p:cNvPr>
-          <p:cNvSpPr>
-            <a:spLocks noGrp="1"/>
-          </p:cNvSpPr>
-          <p:nvPr>
-            <p:ph sz="half" idx="4294967295"/>
-          </p:nvPr>
-        </p:nvSpPr>
-        <p:spPr>
-          <a:xfrm>
-            <a:off x="1483924" y="8096624"/>
-            <a:ext cx="28333429" cy="3089440"/>
-          </a:xfrm>
-          <a:prstGeom prst="rect">
-            <a:avLst/>
-          </a:prstGeom>
-        </p:spPr>
-        <p:txBody>
-          <a:bodyPr/>
-          <a:lstStyle/>
-          <a:p>
-            <a:endParaRPr lang="en-US"/>
-          </a:p>
-        </p:txBody>
-      </p:sp>
-      <p:sp>
-        <p:nvSpPr>
-          <p:cNvPr id="24" name="Picture Placeholder 23">
-            <a:extLst>
-              <a:ext uri="{FF2B5EF4-FFF2-40B4-BE49-F238E27FC236}">
-                <a16:creationId xmlns:a16="http://schemas.microsoft.com/office/drawing/2014/main" id="{59D31A29-0E76-F844-B404-A7F3A9B15180}"/>
-              </a:ext>
-            </a:extLst>
-          </p:cNvPr>
-          <p:cNvSpPr>
-            <a:spLocks noGrp="1"/>
-          </p:cNvSpPr>
-          <p:nvPr>
-            <p:ph type="pic" sz="quarter" idx="4294967295"/>
-          </p:nvPr>
-        </p:nvSpPr>
-        <p:spPr>
-          <a:xfrm>
-            <a:off x="26700480" y="747212"/>
-            <a:ext cx="3116874" cy="5413122"/>
-          </a:xfrm>
-          <a:prstGeom prst="rect">
-            <a:avLst/>
-          </a:prstGeom>
-        </p:spPr>
-        <p:txBody>
-          <a:bodyPr/>
-          <a:lstStyle/>
-          <a:p>
-            <a:endParaRPr lang="en-US"/>
-          </a:p>
-        </p:txBody>
-      </p:sp>
-      <p:sp>
-        <p:nvSpPr>
-          <p:cNvPr id="12" name="Content Placeholder 2"/>
-          <p:cNvSpPr txBox="1">
-            <a:spLocks/>
-          </p:cNvSpPr>
-          <p:nvPr/>
-        </p:nvSpPr>
-        <p:spPr>
-          <a:xfrm>
-            <a:off x="23728971" y="28528137"/>
-            <a:ext cx="6853057" cy="997458"/>
-          </a:xfrm>
-          <a:prstGeom prst="rect">
-            <a:avLst/>
-          </a:prstGeom>
-          <a:noFill/>
-        </p:spPr>
-        <p:txBody>
-          <a:bodyPr lIns="77714" tIns="38857" rIns="77714" bIns="38857"/>
-          <a:lstStyle>
-            <a:lvl1pPr marL="582060" indent="-423316" algn="l" defTabSz="1828508" rtl="0" eaLnBrk="1" latinLnBrk="0" hangingPunct="1">
-              <a:spcBef>
-                <a:spcPct val="20000"/>
-              </a:spcBef>
-              <a:buFont typeface="Arial"/>
-              <a:buChar char="•"/>
-              <a:tabLst/>
-              <a:defRPr sz="5000" kern="1200">
-                <a:solidFill>
-                  <a:srgbClr val="FFFFFF"/>
-                </a:solidFill>
-                <a:latin typeface="+mn-lt"/>
-                <a:ea typeface="+mn-ea"/>
-                <a:cs typeface="+mn-cs"/>
-              </a:defRPr>
-            </a:lvl1pPr>
-            <a:lvl2pPr marL="2133259" indent="-609503" algn="l" defTabSz="1828508" rtl="0" eaLnBrk="1" latinLnBrk="0" hangingPunct="1">
-              <a:spcBef>
-                <a:spcPct val="20000"/>
-              </a:spcBef>
-              <a:buFont typeface="Arial"/>
-              <a:buChar char="–"/>
-              <a:defRPr sz="4000" kern="1200">
-                <a:solidFill>
-                  <a:srgbClr val="FFFFFF"/>
-                </a:solidFill>
-                <a:latin typeface="+mn-lt"/>
-                <a:ea typeface="+mn-ea"/>
-                <a:cs typeface="+mn-cs"/>
-              </a:defRPr>
-            </a:lvl2pPr>
-            <a:lvl3pPr marL="2590386" indent="-380939" algn="l" defTabSz="1828508" rtl="0" eaLnBrk="1" latinLnBrk="0" hangingPunct="1">
-              <a:spcBef>
-                <a:spcPct val="20000"/>
-              </a:spcBef>
-              <a:buFont typeface="Arial"/>
-              <a:buChar char="•"/>
-              <a:defRPr sz="3583" kern="1200">
-                <a:solidFill>
-                  <a:srgbClr val="FFFFFF"/>
-                </a:solidFill>
-                <a:latin typeface="+mn-lt"/>
-                <a:ea typeface="+mn-ea"/>
-                <a:cs typeface="+mn-cs"/>
-              </a:defRPr>
-            </a:lvl3pPr>
-            <a:lvl4pPr marL="3276076" indent="-380939" algn="l" defTabSz="1828508" rtl="0" eaLnBrk="1" latinLnBrk="0" hangingPunct="1">
-              <a:spcBef>
-                <a:spcPct val="20000"/>
-              </a:spcBef>
-              <a:buFont typeface="Arial"/>
-              <a:buChar char="–"/>
-              <a:defRPr sz="3000" kern="1200">
-                <a:solidFill>
-                  <a:srgbClr val="FFFFFF"/>
-                </a:solidFill>
-                <a:latin typeface="+mn-lt"/>
-                <a:ea typeface="+mn-ea"/>
-                <a:cs typeface="+mn-cs"/>
-              </a:defRPr>
-            </a:lvl4pPr>
-            <a:lvl5pPr marL="3657015" indent="-380939" algn="l" defTabSz="1828508" rtl="0" eaLnBrk="1" latinLnBrk="0" hangingPunct="1">
-              <a:spcBef>
-                <a:spcPct val="20000"/>
-              </a:spcBef>
-              <a:buFont typeface="Arial"/>
-              <a:buChar char="»"/>
-              <a:defRPr sz="3000" kern="1200">
-                <a:solidFill>
-                  <a:srgbClr val="FFFFFF"/>
-                </a:solidFill>
-                <a:latin typeface="+mn-lt"/>
-                <a:ea typeface="+mn-ea"/>
-                <a:cs typeface="+mn-cs"/>
-              </a:defRPr>
-            </a:lvl5pPr>
-            <a:lvl6pPr marL="10056790" indent="-914253" algn="l" defTabSz="1828508" rtl="0" eaLnBrk="1" latinLnBrk="0" hangingPunct="1">
-              <a:spcBef>
-                <a:spcPct val="20000"/>
-              </a:spcBef>
-              <a:buFont typeface="Arial"/>
-              <a:buChar char="•"/>
-              <a:defRPr sz="7083" kern="1200">
-                <a:solidFill>
-                  <a:schemeClr val="tx1"/>
-                </a:solidFill>
-                <a:latin typeface="+mn-lt"/>
-                <a:ea typeface="+mn-ea"/>
-                <a:cs typeface="+mn-cs"/>
-              </a:defRPr>
-            </a:lvl6pPr>
-            <a:lvl7pPr marL="11885298" indent="-914253" algn="l" defTabSz="1828508" rtl="0" eaLnBrk="1" latinLnBrk="0" hangingPunct="1">
-              <a:spcBef>
-                <a:spcPct val="20000"/>
-              </a:spcBef>
-              <a:buFont typeface="Arial"/>
-              <a:buChar char="•"/>
-              <a:defRPr sz="7083" kern="1200">
-                <a:solidFill>
-                  <a:schemeClr val="tx1"/>
-                </a:solidFill>
-                <a:latin typeface="+mn-lt"/>
-                <a:ea typeface="+mn-ea"/>
-                <a:cs typeface="+mn-cs"/>
-              </a:defRPr>
-            </a:lvl7pPr>
-            <a:lvl8pPr marL="13713806" indent="-914253" algn="l" defTabSz="1828508" rtl="0" eaLnBrk="1" latinLnBrk="0" hangingPunct="1">
-              <a:spcBef>
-                <a:spcPct val="20000"/>
-              </a:spcBef>
-              <a:buFont typeface="Arial"/>
-              <a:buChar char="•"/>
-              <a:defRPr sz="7083" kern="1200">
-                <a:solidFill>
-                  <a:schemeClr val="tx1"/>
-                </a:solidFill>
-                <a:latin typeface="+mn-lt"/>
-                <a:ea typeface="+mn-ea"/>
-                <a:cs typeface="+mn-cs"/>
-              </a:defRPr>
-            </a:lvl8pPr>
-            <a:lvl9pPr marL="15542312" indent="-914253" algn="l" defTabSz="1828508" rtl="0" eaLnBrk="1" latinLnBrk="0" hangingPunct="1">
-              <a:spcBef>
-                <a:spcPct val="20000"/>
-              </a:spcBef>
-              <a:buFont typeface="Arial"/>
-              <a:buChar char="•"/>
-              <a:defRPr sz="7083" kern="1200">
-                <a:solidFill>
-                  <a:schemeClr val="tx1"/>
-                </a:solidFill>
-                <a:latin typeface="+mn-lt"/>
-                <a:ea typeface="+mn-ea"/>
-                <a:cs typeface="+mn-cs"/>
-              </a:defRPr>
-            </a:lvl9pPr>
-          </a:lstStyle>
-          <a:p>
-            <a:pPr marL="134932" indent="0">
-              <a:buNone/>
-            </a:pPr>
-            <a:r>
-              <a:rPr lang="en-US" sz="3060" dirty="0"/>
-              <a:t>Add Your Logo and/or project info here</a:t>
-            </a:r>
-          </a:p>
-        </p:txBody>
-      </p:sp>
-      <p:sp>
-        <p:nvSpPr>
-          <p:cNvPr id="13" name="Content Placeholder 2"/>
-          <p:cNvSpPr txBox="1">
-            <a:spLocks/>
-          </p:cNvSpPr>
-          <p:nvPr/>
-        </p:nvSpPr>
-        <p:spPr>
-          <a:xfrm>
-            <a:off x="23728971" y="28992322"/>
-            <a:ext cx="6088380" cy="954278"/>
-          </a:xfrm>
-          <a:prstGeom prst="rect">
-            <a:avLst/>
-          </a:prstGeom>
-          <a:noFill/>
-        </p:spPr>
-        <p:txBody>
-          <a:bodyPr lIns="77714" tIns="38857" rIns="77714" bIns="38857"/>
-          <a:lstStyle>
-            <a:lvl1pPr marL="582060" indent="-423316" algn="l" defTabSz="1828508" rtl="0" eaLnBrk="1" latinLnBrk="0" hangingPunct="1">
-              <a:spcBef>
-                <a:spcPct val="20000"/>
-              </a:spcBef>
-              <a:buFont typeface="Arial"/>
-              <a:buChar char="•"/>
-              <a:tabLst/>
-              <a:defRPr sz="5000" kern="1200">
-                <a:solidFill>
-                  <a:srgbClr val="FFFFFF"/>
-                </a:solidFill>
-                <a:latin typeface="+mn-lt"/>
-                <a:ea typeface="+mn-ea"/>
-                <a:cs typeface="+mn-cs"/>
-              </a:defRPr>
-            </a:lvl1pPr>
-            <a:lvl2pPr marL="2133259" indent="-609503" algn="l" defTabSz="1828508" rtl="0" eaLnBrk="1" latinLnBrk="0" hangingPunct="1">
-              <a:spcBef>
-                <a:spcPct val="20000"/>
-              </a:spcBef>
-              <a:buFont typeface="Arial"/>
-              <a:buChar char="–"/>
-              <a:defRPr sz="4000" kern="1200">
-                <a:solidFill>
-                  <a:srgbClr val="FFFFFF"/>
-                </a:solidFill>
-                <a:latin typeface="+mn-lt"/>
-                <a:ea typeface="+mn-ea"/>
-                <a:cs typeface="+mn-cs"/>
-              </a:defRPr>
-            </a:lvl2pPr>
-            <a:lvl3pPr marL="2590386" indent="-380939" algn="l" defTabSz="1828508" rtl="0" eaLnBrk="1" latinLnBrk="0" hangingPunct="1">
-              <a:spcBef>
-                <a:spcPct val="20000"/>
-              </a:spcBef>
-              <a:buFont typeface="Arial"/>
-              <a:buChar char="•"/>
-              <a:defRPr sz="3583" kern="1200">
-                <a:solidFill>
-                  <a:srgbClr val="FFFFFF"/>
-                </a:solidFill>
-                <a:latin typeface="+mn-lt"/>
-                <a:ea typeface="+mn-ea"/>
-                <a:cs typeface="+mn-cs"/>
-              </a:defRPr>
-            </a:lvl3pPr>
-            <a:lvl4pPr marL="3276076" indent="-380939" algn="l" defTabSz="1828508" rtl="0" eaLnBrk="1" latinLnBrk="0" hangingPunct="1">
-              <a:spcBef>
-                <a:spcPct val="20000"/>
-              </a:spcBef>
-              <a:buFont typeface="Arial"/>
-              <a:buChar char="–"/>
-              <a:defRPr sz="3000" kern="1200">
-                <a:solidFill>
-                  <a:srgbClr val="FFFFFF"/>
-                </a:solidFill>
-                <a:latin typeface="+mn-lt"/>
-                <a:ea typeface="+mn-ea"/>
-                <a:cs typeface="+mn-cs"/>
-              </a:defRPr>
-            </a:lvl4pPr>
-            <a:lvl5pPr marL="3657015" indent="-380939" algn="l" defTabSz="1828508" rtl="0" eaLnBrk="1" latinLnBrk="0" hangingPunct="1">
-              <a:spcBef>
-                <a:spcPct val="20000"/>
-              </a:spcBef>
-              <a:buFont typeface="Arial"/>
-              <a:buChar char="»"/>
-              <a:defRPr sz="3000" kern="1200">
-                <a:solidFill>
-                  <a:srgbClr val="FFFFFF"/>
-                </a:solidFill>
-                <a:latin typeface="+mn-lt"/>
-                <a:ea typeface="+mn-ea"/>
-                <a:cs typeface="+mn-cs"/>
-              </a:defRPr>
-            </a:lvl5pPr>
-            <a:lvl6pPr marL="10056790" indent="-914253" algn="l" defTabSz="1828508" rtl="0" eaLnBrk="1" latinLnBrk="0" hangingPunct="1">
-              <a:spcBef>
-                <a:spcPct val="20000"/>
-              </a:spcBef>
-              <a:buFont typeface="Arial"/>
-              <a:buChar char="•"/>
-              <a:defRPr sz="7083" kern="1200">
-                <a:solidFill>
-                  <a:schemeClr val="tx1"/>
-                </a:solidFill>
-                <a:latin typeface="+mn-lt"/>
-                <a:ea typeface="+mn-ea"/>
-                <a:cs typeface="+mn-cs"/>
-              </a:defRPr>
-            </a:lvl6pPr>
-            <a:lvl7pPr marL="11885298" indent="-914253" algn="l" defTabSz="1828508" rtl="0" eaLnBrk="1" latinLnBrk="0" hangingPunct="1">
-              <a:spcBef>
-                <a:spcPct val="20000"/>
-              </a:spcBef>
-              <a:buFont typeface="Arial"/>
-              <a:buChar char="•"/>
-              <a:defRPr sz="7083" kern="1200">
-                <a:solidFill>
-                  <a:schemeClr val="tx1"/>
-                </a:solidFill>
-                <a:latin typeface="+mn-lt"/>
-                <a:ea typeface="+mn-ea"/>
-                <a:cs typeface="+mn-cs"/>
-              </a:defRPr>
-            </a:lvl7pPr>
-            <a:lvl8pPr marL="13713806" indent="-914253" algn="l" defTabSz="1828508" rtl="0" eaLnBrk="1" latinLnBrk="0" hangingPunct="1">
-              <a:spcBef>
-                <a:spcPct val="20000"/>
-              </a:spcBef>
-              <a:buFont typeface="Arial"/>
-              <a:buChar char="•"/>
-              <a:defRPr sz="7083" kern="1200">
-                <a:solidFill>
-                  <a:schemeClr val="tx1"/>
-                </a:solidFill>
-                <a:latin typeface="+mn-lt"/>
-                <a:ea typeface="+mn-ea"/>
-                <a:cs typeface="+mn-cs"/>
-              </a:defRPr>
-            </a:lvl8pPr>
-            <a:lvl9pPr marL="15542312" indent="-914253" algn="l" defTabSz="1828508" rtl="0" eaLnBrk="1" latinLnBrk="0" hangingPunct="1">
-              <a:spcBef>
-                <a:spcPct val="20000"/>
-              </a:spcBef>
-              <a:buFont typeface="Arial"/>
-              <a:buChar char="•"/>
-              <a:defRPr sz="7083" kern="1200">
-                <a:solidFill>
-                  <a:schemeClr val="tx1"/>
-                </a:solidFill>
-                <a:latin typeface="+mn-lt"/>
-                <a:ea typeface="+mn-ea"/>
-                <a:cs typeface="+mn-cs"/>
-              </a:defRPr>
-            </a:lvl9pPr>
-          </a:lstStyle>
-          <a:p>
-            <a:pPr marL="134932" indent="0">
-              <a:buNone/>
-            </a:pPr>
-            <a:r>
-              <a:rPr lang="en-US" sz="3060"/>
-              <a:t>Award ID#:</a:t>
-            </a:r>
-            <a:endParaRPr lang="en-US" sz="3060" dirty="0"/>
           </a:p>
         </p:txBody>
       </p:sp>
     </p:spTree>
     <p:extLst>
       <p:ext uri="{BB962C8B-B14F-4D97-AF65-F5344CB8AC3E}">
-        <p14:creationId xmlns:p14="http://schemas.microsoft.com/office/powerpoint/2010/main" val="950205223"/>
+        <p14:creationId xmlns:p14="http://schemas.microsoft.com/office/powerpoint/2010/main" val="2872811403"/>
       </p:ext>
     </p:extLst>
   </p:cSld>

</xml_diff>

<commit_message>
oops changes didn't save
</commit_message>
<xml_diff>
--- a/assets/downloads/cici-IPAAI-pi-poster-template-2026.pptx
+++ b/assets/downloads/cici-IPAAI-pi-poster-template-2026.pptx
@@ -8,7 +8,7 @@
     <p:notesMasterId r:id="rId3"/>
   </p:notesMasterIdLst>
   <p:sldIdLst>
-    <p:sldId id="261" r:id="rId2"/>
+    <p:sldId id="262" r:id="rId2"/>
   </p:sldIdLst>
   <p:sldSz cx="31089600" cy="36576000"/>
   <p:notesSz cx="6858000" cy="9144000"/>
@@ -741,8 +741,8 @@
         </p:nvSpPr>
         <p:spPr>
           <a:xfrm>
-            <a:off x="11108827" y="25742481"/>
-            <a:ext cx="9137409" cy="7805687"/>
+            <a:off x="11108827" y="25570859"/>
+            <a:ext cx="9134856" cy="7805687"/>
           </a:xfrm>
           <a:prstGeom prst="rect">
             <a:avLst/>
@@ -984,7 +984,7 @@
         </p:nvSpPr>
         <p:spPr>
           <a:xfrm>
-            <a:off x="1510817" y="25742481"/>
+            <a:off x="1510817" y="25570859"/>
             <a:ext cx="9134856" cy="7805687"/>
           </a:xfrm>
           <a:prstGeom prst="rect">
@@ -1105,8 +1105,8 @@
         </p:nvSpPr>
         <p:spPr>
           <a:xfrm>
-            <a:off x="20706836" y="25742481"/>
-            <a:ext cx="9137409" cy="7805687"/>
+            <a:off x="20706836" y="25570859"/>
+            <a:ext cx="9134856" cy="7805687"/>
           </a:xfrm>
           <a:prstGeom prst="rect">
             <a:avLst/>
@@ -1953,7 +1953,7 @@
           <p:cNvPr id="2" name="Title 1">
             <a:extLst>
               <a:ext uri="{FF2B5EF4-FFF2-40B4-BE49-F238E27FC236}">
-                <a16:creationId xmlns:a16="http://schemas.microsoft.com/office/drawing/2014/main" id="{A3706610-4C03-E056-DF73-45895AFE74EB}"/>
+                <a16:creationId xmlns:a16="http://schemas.microsoft.com/office/drawing/2014/main" id="{5E64577F-52F6-8D08-3F35-CC63D8343BE4}"/>
               </a:ext>
             </a:extLst>
           </p:cNvPr>
@@ -1978,7 +1978,7 @@
           <p:cNvPr id="3" name="Text Placeholder 2">
             <a:extLst>
               <a:ext uri="{FF2B5EF4-FFF2-40B4-BE49-F238E27FC236}">
-                <a16:creationId xmlns:a16="http://schemas.microsoft.com/office/drawing/2014/main" id="{F132697F-8AE1-7708-4E66-F54B96933BA5}"/>
+                <a16:creationId xmlns:a16="http://schemas.microsoft.com/office/drawing/2014/main" id="{A958820E-8630-D5C5-C86B-66B029D6D225}"/>
               </a:ext>
             </a:extLst>
           </p:cNvPr>
@@ -2003,7 +2003,7 @@
           <p:cNvPr id="4" name="Text Placeholder 3">
             <a:extLst>
               <a:ext uri="{FF2B5EF4-FFF2-40B4-BE49-F238E27FC236}">
-                <a16:creationId xmlns:a16="http://schemas.microsoft.com/office/drawing/2014/main" id="{82486F73-0BE6-1D4D-6AAF-36F2BE5AA7CD}"/>
+                <a16:creationId xmlns:a16="http://schemas.microsoft.com/office/drawing/2014/main" id="{9C7BF94D-5CE8-C365-B7CB-C5451BC495F1}"/>
               </a:ext>
             </a:extLst>
           </p:cNvPr>
@@ -2028,7 +2028,7 @@
           <p:cNvPr id="5" name="Content Placeholder 4">
             <a:extLst>
               <a:ext uri="{FF2B5EF4-FFF2-40B4-BE49-F238E27FC236}">
-                <a16:creationId xmlns:a16="http://schemas.microsoft.com/office/drawing/2014/main" id="{E86B27C0-37CF-6529-D424-F4D0836DD412}"/>
+                <a16:creationId xmlns:a16="http://schemas.microsoft.com/office/drawing/2014/main" id="{E6A08A0E-4A96-B8C5-8095-FF33FBD52A8A}"/>
               </a:ext>
             </a:extLst>
           </p:cNvPr>
@@ -2053,7 +2053,7 @@
           <p:cNvPr id="6" name="Content Placeholder 5">
             <a:extLst>
               <a:ext uri="{FF2B5EF4-FFF2-40B4-BE49-F238E27FC236}">
-                <a16:creationId xmlns:a16="http://schemas.microsoft.com/office/drawing/2014/main" id="{745766B9-A84A-C223-673D-400D75EA412F}"/>
+                <a16:creationId xmlns:a16="http://schemas.microsoft.com/office/drawing/2014/main" id="{2BC448C9-EF3B-E475-C8ED-1CB167F167D5}"/>
               </a:ext>
             </a:extLst>
           </p:cNvPr>
@@ -2078,7 +2078,7 @@
           <p:cNvPr id="7" name="Content Placeholder 6">
             <a:extLst>
               <a:ext uri="{FF2B5EF4-FFF2-40B4-BE49-F238E27FC236}">
-                <a16:creationId xmlns:a16="http://schemas.microsoft.com/office/drawing/2014/main" id="{84BC5E4B-B472-91B6-D23B-AC61884A57CD}"/>
+                <a16:creationId xmlns:a16="http://schemas.microsoft.com/office/drawing/2014/main" id="{CF95D726-A240-FF95-8ACC-D27C4504C5C8}"/>
               </a:ext>
             </a:extLst>
           </p:cNvPr>
@@ -2103,7 +2103,7 @@
           <p:cNvPr id="8" name="Content Placeholder 7">
             <a:extLst>
               <a:ext uri="{FF2B5EF4-FFF2-40B4-BE49-F238E27FC236}">
-                <a16:creationId xmlns:a16="http://schemas.microsoft.com/office/drawing/2014/main" id="{28E2AA64-37BF-5607-1805-5A4ED4CCEBA5}"/>
+                <a16:creationId xmlns:a16="http://schemas.microsoft.com/office/drawing/2014/main" id="{2BE1F68D-2F4A-46FE-8319-41E69B90B672}"/>
               </a:ext>
             </a:extLst>
           </p:cNvPr>
@@ -2128,7 +2128,7 @@
           <p:cNvPr id="9" name="Content Placeholder 8">
             <a:extLst>
               <a:ext uri="{FF2B5EF4-FFF2-40B4-BE49-F238E27FC236}">
-                <a16:creationId xmlns:a16="http://schemas.microsoft.com/office/drawing/2014/main" id="{4B47F05C-1637-5194-6FBC-811A38725242}"/>
+                <a16:creationId xmlns:a16="http://schemas.microsoft.com/office/drawing/2014/main" id="{0187413C-74EB-4885-6734-5629F0EBC237}"/>
               </a:ext>
             </a:extLst>
           </p:cNvPr>
@@ -2153,7 +2153,7 @@
           <p:cNvPr id="10" name="Content Placeholder 9">
             <a:extLst>
               <a:ext uri="{FF2B5EF4-FFF2-40B4-BE49-F238E27FC236}">
-                <a16:creationId xmlns:a16="http://schemas.microsoft.com/office/drawing/2014/main" id="{BFE1EE19-396C-2C58-D4CE-57866851AD09}"/>
+                <a16:creationId xmlns:a16="http://schemas.microsoft.com/office/drawing/2014/main" id="{AA6D4636-92CB-5DE1-2315-338901DADA6E}"/>
               </a:ext>
             </a:extLst>
           </p:cNvPr>
@@ -2176,7 +2176,7 @@
     </p:spTree>
     <p:extLst>
       <p:ext uri="{BB962C8B-B14F-4D97-AF65-F5344CB8AC3E}">
-        <p14:creationId xmlns:p14="http://schemas.microsoft.com/office/powerpoint/2010/main" val="2872811403"/>
+        <p14:creationId xmlns:p14="http://schemas.microsoft.com/office/powerpoint/2010/main" val="3850293611"/>
       </p:ext>
     </p:extLst>
   </p:cSld>

</xml_diff>

<commit_message>
I give up on centering perfectly
</commit_message>
<xml_diff>
--- a/assets/downloads/cici-IPAAI-pi-poster-template-2026.pptx
+++ b/assets/downloads/cici-IPAAI-pi-poster-template-2026.pptx
@@ -741,7 +741,7 @@
         </p:nvSpPr>
         <p:spPr>
           <a:xfrm>
-            <a:off x="11108827" y="25570859"/>
+            <a:off x="11110103" y="25570859"/>
             <a:ext cx="9134856" cy="7805687"/>
           </a:xfrm>
           <a:prstGeom prst="rect">
@@ -2044,7 +2044,7 @@
           <a:bodyPr/>
           <a:lstStyle/>
           <a:p>
-            <a:endParaRPr lang="en-US"/>
+            <a:endParaRPr lang="en-US" dirty="0"/>
           </a:p>
         </p:txBody>
       </p:sp>
@@ -2119,7 +2119,7 @@
           <a:bodyPr/>
           <a:lstStyle/>
           <a:p>
-            <a:endParaRPr lang="en-US"/>
+            <a:endParaRPr lang="en-US" dirty="0"/>
           </a:p>
         </p:txBody>
       </p:sp>

</xml_diff>